<commit_message>
Agrega multiples conexiones BD al proyecto
</commit_message>
<xml_diff>
--- a/docs/Lineamiento_desarrollo.pptx
+++ b/docs/Lineamiento_desarrollo.pptx
@@ -118,22 +118,125 @@
   <pc:docChgLst>
     <pc:chgData name="Fernando Valdés" userId="eab78425898f3222" providerId="LiveId" clId="{F45BFA98-325B-4494-A0D3-754FF278606F}"/>
     <pc:docChg chg="modSld">
-      <pc:chgData name="Fernando Valdés" userId="eab78425898f3222" providerId="LiveId" clId="{F45BFA98-325B-4494-A0D3-754FF278606F}" dt="2026-09-15T16:00:49.278" v="12" actId="20577"/>
+      <pc:chgData name="Fernando Valdés" userId="eab78425898f3222" providerId="LiveId" clId="{F45BFA98-325B-4494-A0D3-754FF278606F}" dt="2026-10-19T18:27:51.662" v="48" actId="255"/>
       <pc:docMkLst>
         <pc:docMk/>
       </pc:docMkLst>
       <pc:sldChg chg="modSp mod">
-        <pc:chgData name="Fernando Valdés" userId="eab78425898f3222" providerId="LiveId" clId="{F45BFA98-325B-4494-A0D3-754FF278606F}" dt="2026-09-15T16:00:49.278" v="12" actId="20577"/>
+        <pc:chgData name="Fernando Valdés" userId="eab78425898f3222" providerId="LiveId" clId="{F45BFA98-325B-4494-A0D3-754FF278606F}" dt="2026-10-19T18:27:51.662" v="48" actId="255"/>
         <pc:sldMkLst>
           <pc:docMk/>
           <pc:sldMk cId="3288402631" sldId="256"/>
         </pc:sldMkLst>
         <pc:spChg chg="mod">
-          <ac:chgData name="Fernando Valdés" userId="eab78425898f3222" providerId="LiveId" clId="{F45BFA98-325B-4494-A0D3-754FF278606F}" dt="2026-09-15T16:00:49.278" v="12" actId="20577"/>
+          <ac:chgData name="Fernando Valdés" userId="eab78425898f3222" providerId="LiveId" clId="{F45BFA98-325B-4494-A0D3-754FF278606F}" dt="2026-10-19T18:27:42.499" v="47" actId="1036"/>
           <ac:spMkLst>
             <pc:docMk/>
             <pc:sldMk cId="3288402631" sldId="256"/>
             <ac:spMk id="7" creationId="{00000000-0000-0000-0000-000000000000}"/>
+          </ac:spMkLst>
+        </pc:spChg>
+        <pc:spChg chg="mod">
+          <ac:chgData name="Fernando Valdés" userId="eab78425898f3222" providerId="LiveId" clId="{F45BFA98-325B-4494-A0D3-754FF278606F}" dt="2026-10-19T18:27:51.662" v="48" actId="255"/>
+          <ac:spMkLst>
+            <pc:docMk/>
+            <pc:sldMk cId="3288402631" sldId="256"/>
+            <ac:spMk id="11" creationId="{00000000-0000-0000-0000-000000000000}"/>
+          </ac:spMkLst>
+        </pc:spChg>
+        <pc:spChg chg="mod">
+          <ac:chgData name="Fernando Valdés" userId="eab78425898f3222" providerId="LiveId" clId="{F45BFA98-325B-4494-A0D3-754FF278606F}" dt="2026-10-19T18:27:17.708" v="33" actId="14100"/>
+          <ac:spMkLst>
+            <pc:docMk/>
+            <pc:sldMk cId="3288402631" sldId="256"/>
+            <ac:spMk id="35" creationId="{00000000-0000-0000-0000-000000000000}"/>
+          </ac:spMkLst>
+        </pc:spChg>
+        <pc:spChg chg="mod">
+          <ac:chgData name="Fernando Valdés" userId="eab78425898f3222" providerId="LiveId" clId="{F45BFA98-325B-4494-A0D3-754FF278606F}" dt="2026-10-19T18:27:03.778" v="31" actId="255"/>
+          <ac:spMkLst>
+            <pc:docMk/>
+            <pc:sldMk cId="3288402631" sldId="256"/>
+            <ac:spMk id="50" creationId="{00000000-0000-0000-0000-000000000000}"/>
+          </ac:spMkLst>
+        </pc:spChg>
+        <pc:spChg chg="mod">
+          <ac:chgData name="Fernando Valdés" userId="eab78425898f3222" providerId="LiveId" clId="{F45BFA98-325B-4494-A0D3-754FF278606F}" dt="2026-10-19T18:27:03.778" v="31" actId="255"/>
+          <ac:spMkLst>
+            <pc:docMk/>
+            <pc:sldMk cId="3288402631" sldId="256"/>
+            <ac:spMk id="53" creationId="{00000000-0000-0000-0000-000000000000}"/>
+          </ac:spMkLst>
+        </pc:spChg>
+        <pc:spChg chg="mod">
+          <ac:chgData name="Fernando Valdés" userId="eab78425898f3222" providerId="LiveId" clId="{F45BFA98-325B-4494-A0D3-754FF278606F}" dt="2026-10-19T18:27:03.778" v="31" actId="255"/>
+          <ac:spMkLst>
+            <pc:docMk/>
+            <pc:sldMk cId="3288402631" sldId="256"/>
+            <ac:spMk id="56" creationId="{00000000-0000-0000-0000-000000000000}"/>
+          </ac:spMkLst>
+        </pc:spChg>
+        <pc:spChg chg="mod">
+          <ac:chgData name="Fernando Valdés" userId="eab78425898f3222" providerId="LiveId" clId="{F45BFA98-325B-4494-A0D3-754FF278606F}" dt="2026-10-19T18:27:03.778" v="31" actId="255"/>
+          <ac:spMkLst>
+            <pc:docMk/>
+            <pc:sldMk cId="3288402631" sldId="256"/>
+            <ac:spMk id="59" creationId="{00000000-0000-0000-0000-000000000000}"/>
+          </ac:spMkLst>
+        </pc:spChg>
+        <pc:spChg chg="mod">
+          <ac:chgData name="Fernando Valdés" userId="eab78425898f3222" providerId="LiveId" clId="{F45BFA98-325B-4494-A0D3-754FF278606F}" dt="2026-10-19T18:27:03.778" v="31" actId="255"/>
+          <ac:spMkLst>
+            <pc:docMk/>
+            <pc:sldMk cId="3288402631" sldId="256"/>
+            <ac:spMk id="62" creationId="{00000000-0000-0000-0000-000000000000}"/>
+          </ac:spMkLst>
+        </pc:spChg>
+        <pc:spChg chg="mod">
+          <ac:chgData name="Fernando Valdés" userId="eab78425898f3222" providerId="LiveId" clId="{F45BFA98-325B-4494-A0D3-754FF278606F}" dt="2026-10-19T18:27:03.778" v="31" actId="255"/>
+          <ac:spMkLst>
+            <pc:docMk/>
+            <pc:sldMk cId="3288402631" sldId="256"/>
+            <ac:spMk id="65" creationId="{00000000-0000-0000-0000-000000000000}"/>
+          </ac:spMkLst>
+        </pc:spChg>
+        <pc:spChg chg="mod">
+          <ac:chgData name="Fernando Valdés" userId="eab78425898f3222" providerId="LiveId" clId="{F45BFA98-325B-4494-A0D3-754FF278606F}" dt="2026-10-19T18:27:03.778" v="31" actId="255"/>
+          <ac:spMkLst>
+            <pc:docMk/>
+            <pc:sldMk cId="3288402631" sldId="256"/>
+            <ac:spMk id="68" creationId="{00000000-0000-0000-0000-000000000000}"/>
+          </ac:spMkLst>
+        </pc:spChg>
+        <pc:spChg chg="mod">
+          <ac:chgData name="Fernando Valdés" userId="eab78425898f3222" providerId="LiveId" clId="{F45BFA98-325B-4494-A0D3-754FF278606F}" dt="2026-10-19T18:27:03.778" v="31" actId="255"/>
+          <ac:spMkLst>
+            <pc:docMk/>
+            <pc:sldMk cId="3288402631" sldId="256"/>
+            <ac:spMk id="71" creationId="{00000000-0000-0000-0000-000000000000}"/>
+          </ac:spMkLst>
+        </pc:spChg>
+      </pc:sldChg>
+      <pc:sldChg chg="modSp mod">
+        <pc:chgData name="Fernando Valdés" userId="eab78425898f3222" providerId="LiveId" clId="{F45BFA98-325B-4494-A0D3-754FF278606F}" dt="2026-10-19T18:22:40.171" v="29" actId="20577"/>
+        <pc:sldMkLst>
+          <pc:docMk/>
+          <pc:sldMk cId="102942647" sldId="276"/>
+        </pc:sldMkLst>
+        <pc:spChg chg="mod">
+          <ac:chgData name="Fernando Valdés" userId="eab78425898f3222" providerId="LiveId" clId="{F45BFA98-325B-4494-A0D3-754FF278606F}" dt="2026-10-19T18:22:40.171" v="29" actId="20577"/>
+          <ac:spMkLst>
+            <pc:docMk/>
+            <pc:sldMk cId="102942647" sldId="276"/>
+            <ac:spMk id="17" creationId="{0202A225-4C0A-DDBA-7FDD-418640973113}"/>
+          </ac:spMkLst>
+        </pc:spChg>
+        <pc:spChg chg="mod">
+          <ac:chgData name="Fernando Valdés" userId="eab78425898f3222" providerId="LiveId" clId="{F45BFA98-325B-4494-A0D3-754FF278606F}" dt="2026-10-19T18:22:27.640" v="21" actId="20577"/>
+          <ac:spMkLst>
+            <pc:docMk/>
+            <pc:sldMk cId="102942647" sldId="276"/>
+            <ac:spMk id="21" creationId="{2D7A97B1-2BE4-B0A9-98BA-B1C00215DD28}"/>
           </ac:spMkLst>
         </pc:spChg>
       </pc:sldChg>
@@ -291,7 +394,7 @@
           <a:p>
             <a:fld id="{C7C5CB08-DCA1-48A9-92CC-D574376F6F56}" type="datetimeFigureOut">
               <a:rPr lang="es-CL" smtClean="0"/>
-              <a:t>15-09-2026</a:t>
+              <a:t>19-10-2026</a:t>
             </a:fld>
             <a:endParaRPr lang="es-CL"/>
           </a:p>
@@ -491,7 +594,7 @@
           <a:p>
             <a:fld id="{C7C5CB08-DCA1-48A9-92CC-D574376F6F56}" type="datetimeFigureOut">
               <a:rPr lang="es-CL" smtClean="0"/>
-              <a:t>15-09-2026</a:t>
+              <a:t>19-10-2026</a:t>
             </a:fld>
             <a:endParaRPr lang="es-CL"/>
           </a:p>
@@ -701,7 +804,7 @@
           <a:p>
             <a:fld id="{C7C5CB08-DCA1-48A9-92CC-D574376F6F56}" type="datetimeFigureOut">
               <a:rPr lang="es-CL" smtClean="0"/>
-              <a:t>15-09-2026</a:t>
+              <a:t>19-10-2026</a:t>
             </a:fld>
             <a:endParaRPr lang="es-CL"/>
           </a:p>
@@ -901,7 +1004,7 @@
           <a:p>
             <a:fld id="{C7C5CB08-DCA1-48A9-92CC-D574376F6F56}" type="datetimeFigureOut">
               <a:rPr lang="es-CL" smtClean="0"/>
-              <a:t>15-09-2026</a:t>
+              <a:t>19-10-2026</a:t>
             </a:fld>
             <a:endParaRPr lang="es-CL"/>
           </a:p>
@@ -1177,7 +1280,7 @@
           <a:p>
             <a:fld id="{C7C5CB08-DCA1-48A9-92CC-D574376F6F56}" type="datetimeFigureOut">
               <a:rPr lang="es-CL" smtClean="0"/>
-              <a:t>15-09-2026</a:t>
+              <a:t>19-10-2026</a:t>
             </a:fld>
             <a:endParaRPr lang="es-CL"/>
           </a:p>
@@ -1445,7 +1548,7 @@
           <a:p>
             <a:fld id="{C7C5CB08-DCA1-48A9-92CC-D574376F6F56}" type="datetimeFigureOut">
               <a:rPr lang="es-CL" smtClean="0"/>
-              <a:t>15-09-2026</a:t>
+              <a:t>19-10-2026</a:t>
             </a:fld>
             <a:endParaRPr lang="es-CL"/>
           </a:p>
@@ -1860,7 +1963,7 @@
           <a:p>
             <a:fld id="{C7C5CB08-DCA1-48A9-92CC-D574376F6F56}" type="datetimeFigureOut">
               <a:rPr lang="es-CL" smtClean="0"/>
-              <a:t>15-09-2026</a:t>
+              <a:t>19-10-2026</a:t>
             </a:fld>
             <a:endParaRPr lang="es-CL"/>
           </a:p>
@@ -2002,7 +2105,7 @@
           <a:p>
             <a:fld id="{C7C5CB08-DCA1-48A9-92CC-D574376F6F56}" type="datetimeFigureOut">
               <a:rPr lang="es-CL" smtClean="0"/>
-              <a:t>15-09-2026</a:t>
+              <a:t>19-10-2026</a:t>
             </a:fld>
             <a:endParaRPr lang="es-CL"/>
           </a:p>
@@ -2115,7 +2218,7 @@
           <a:p>
             <a:fld id="{C7C5CB08-DCA1-48A9-92CC-D574376F6F56}" type="datetimeFigureOut">
               <a:rPr lang="es-CL" smtClean="0"/>
-              <a:t>15-09-2026</a:t>
+              <a:t>19-10-2026</a:t>
             </a:fld>
             <a:endParaRPr lang="es-CL"/>
           </a:p>
@@ -2428,7 +2531,7 @@
           <a:p>
             <a:fld id="{C7C5CB08-DCA1-48A9-92CC-D574376F6F56}" type="datetimeFigureOut">
               <a:rPr lang="es-CL" smtClean="0"/>
-              <a:t>15-09-2026</a:t>
+              <a:t>19-10-2026</a:t>
             </a:fld>
             <a:endParaRPr lang="es-CL"/>
           </a:p>
@@ -2717,7 +2820,7 @@
           <a:p>
             <a:fld id="{C7C5CB08-DCA1-48A9-92CC-D574376F6F56}" type="datetimeFigureOut">
               <a:rPr lang="es-CL" smtClean="0"/>
-              <a:t>15-09-2026</a:t>
+              <a:t>19-10-2026</a:t>
             </a:fld>
             <a:endParaRPr lang="es-CL"/>
           </a:p>
@@ -2960,7 +3063,7 @@
           <a:p>
             <a:fld id="{C7C5CB08-DCA1-48A9-92CC-D574376F6F56}" type="datetimeFigureOut">
               <a:rPr lang="es-CL" smtClean="0"/>
-              <a:t>15-09-2026</a:t>
+              <a:t>19-10-2026</a:t>
             </a:fld>
             <a:endParaRPr lang="es-CL"/>
           </a:p>
@@ -3602,8 +3705,8 @@
         </p:nvSpPr>
         <p:spPr>
           <a:xfrm>
-            <a:off x="521207" y="1280160"/>
-            <a:ext cx="4946903" cy="1042337"/>
+            <a:off x="521207" y="1211151"/>
+            <a:ext cx="4946903" cy="1088503"/>
           </a:xfrm>
           <a:prstGeom prst="rect">
             <a:avLst/>
@@ -3622,7 +3725,7 @@
               </a:spcAft>
             </a:pPr>
             <a:r>
-              <a:rPr sz="950" b="0" i="0" dirty="0">
+              <a:rPr sz="1000" b="0" i="0" dirty="0">
                 <a:solidFill>
                   <a:srgbClr val="2D3748"/>
                 </a:solidFill>
@@ -3631,7 +3734,7 @@
               <a:t>•  </a:t>
             </a:r>
             <a:r>
-              <a:rPr sz="950" b="0" i="0" dirty="0" err="1">
+              <a:rPr sz="1000" b="0" i="0" dirty="0" err="1">
                 <a:solidFill>
                   <a:srgbClr val="2D3748"/>
                 </a:solidFill>
@@ -3640,7 +3743,7 @@
               <a:t>Funcionamiento</a:t>
             </a:r>
             <a:r>
-              <a:rPr sz="950" b="0" i="0" dirty="0">
+              <a:rPr sz="1000" b="0" i="0" dirty="0">
                 <a:solidFill>
                   <a:srgbClr val="2D3748"/>
                 </a:solidFill>
@@ -3649,7 +3752,7 @@
               <a:t> </a:t>
             </a:r>
             <a:r>
-              <a:rPr sz="950" b="0" i="0" dirty="0" err="1">
+              <a:rPr sz="1000" b="0" i="0" dirty="0" err="1">
                 <a:solidFill>
                   <a:srgbClr val="2D3748"/>
                 </a:solidFill>
@@ -3658,7 +3761,7 @@
               <a:t>sobre</a:t>
             </a:r>
             <a:r>
-              <a:rPr sz="950" b="0" i="0" dirty="0">
+              <a:rPr sz="1000" b="0" i="0" dirty="0">
                 <a:solidFill>
                   <a:srgbClr val="2D3748"/>
                 </a:solidFill>
@@ -3667,7 +3770,7 @@
               <a:t> </a:t>
             </a:r>
             <a:r>
-              <a:rPr sz="950" b="0" i="0" dirty="0" err="1">
+              <a:rPr sz="1000" b="0" i="0" dirty="0" err="1">
                 <a:solidFill>
                   <a:srgbClr val="2D3748"/>
                 </a:solidFill>
@@ -3676,7 +3779,7 @@
               <a:t>protocolo</a:t>
             </a:r>
             <a:r>
-              <a:rPr sz="950" b="0" i="0" dirty="0">
+              <a:rPr sz="1000" b="0" i="0" dirty="0">
                 <a:solidFill>
                   <a:srgbClr val="2D3748"/>
                 </a:solidFill>
@@ -3692,7 +3795,7 @@
               </a:spcAft>
             </a:pPr>
             <a:r>
-              <a:rPr sz="950" b="0" i="0" dirty="0">
+              <a:rPr sz="1000" b="0" i="0" dirty="0">
                 <a:solidFill>
                   <a:srgbClr val="2D3748"/>
                 </a:solidFill>
@@ -3701,7 +3804,7 @@
               <a:t>•  </a:t>
             </a:r>
             <a:r>
-              <a:rPr sz="950" b="0" i="0" dirty="0" err="1">
+              <a:rPr sz="1000" b="0" i="0" dirty="0" err="1">
                 <a:solidFill>
                   <a:srgbClr val="2D3748"/>
                 </a:solidFill>
@@ -3710,7 +3813,7 @@
               <a:t>Separación</a:t>
             </a:r>
             <a:r>
-              <a:rPr sz="950" b="0" i="0" dirty="0">
+              <a:rPr sz="1000" b="0" i="0" dirty="0">
                 <a:solidFill>
                   <a:srgbClr val="2D3748"/>
                 </a:solidFill>
@@ -3719,7 +3822,7 @@
               <a:t> </a:t>
             </a:r>
             <a:r>
-              <a:rPr sz="950" b="0" i="0" dirty="0" err="1">
+              <a:rPr sz="1000" b="0" i="0" dirty="0" err="1">
                 <a:solidFill>
                   <a:srgbClr val="2D3748"/>
                 </a:solidFill>
@@ -3728,7 +3831,7 @@
               <a:t>cliente</a:t>
             </a:r>
             <a:r>
-              <a:rPr sz="950" b="0" i="0" dirty="0">
+              <a:rPr sz="1000" b="0" i="0" dirty="0">
                 <a:solidFill>
                   <a:srgbClr val="2D3748"/>
                 </a:solidFill>
@@ -3737,7 +3840,7 @@
               <a:t> – </a:t>
             </a:r>
             <a:r>
-              <a:rPr sz="950" b="0" i="0" dirty="0" err="1">
+              <a:rPr sz="1000" b="0" i="0" dirty="0" err="1">
                 <a:solidFill>
                   <a:srgbClr val="2D3748"/>
                 </a:solidFill>
@@ -3745,7 +3848,7 @@
               </a:rPr>
               <a:t>servidor</a:t>
             </a:r>
-            <a:endParaRPr sz="950" b="0" i="0" dirty="0">
+            <a:endParaRPr sz="1000" b="0" i="0" dirty="0">
               <a:solidFill>
                 <a:srgbClr val="2D3748"/>
               </a:solidFill>
@@ -3759,7 +3862,7 @@
               </a:spcAft>
             </a:pPr>
             <a:r>
-              <a:rPr sz="950" b="0" i="0" dirty="0">
+              <a:rPr sz="1000" b="0" i="0" dirty="0">
                 <a:solidFill>
                   <a:srgbClr val="2D3748"/>
                 </a:solidFill>
@@ -3768,7 +3871,7 @@
               <a:t>•  API REST — </a:t>
             </a:r>
             <a:r>
-              <a:rPr sz="950" b="0" i="0" dirty="0" err="1">
+              <a:rPr sz="1000" b="0" i="0" dirty="0" err="1">
                 <a:solidFill>
                   <a:srgbClr val="2D3748"/>
                 </a:solidFill>
@@ -3777,7 +3880,7 @@
               <a:t>diseño</a:t>
             </a:r>
             <a:r>
-              <a:rPr sz="950" b="0" i="0" dirty="0">
+              <a:rPr sz="1000" b="0" i="0" dirty="0">
                 <a:solidFill>
                   <a:srgbClr val="2D3748"/>
                 </a:solidFill>
@@ -3786,7 +3889,7 @@
               <a:t> </a:t>
             </a:r>
             <a:r>
-              <a:rPr sz="950" b="0" i="0" dirty="0" err="1">
+              <a:rPr sz="1000" b="0" i="0" dirty="0" err="1">
                 <a:solidFill>
                   <a:srgbClr val="2D3748"/>
                 </a:solidFill>
@@ -3795,7 +3898,7 @@
               <a:t>en</a:t>
             </a:r>
             <a:r>
-              <a:rPr sz="950" b="0" i="0" dirty="0">
+              <a:rPr sz="1000" b="0" i="0" dirty="0">
                 <a:solidFill>
                   <a:srgbClr val="2D3748"/>
                 </a:solidFill>
@@ -3811,7 +3914,7 @@
               </a:spcAft>
             </a:pPr>
             <a:r>
-              <a:rPr sz="950" b="0" i="0" dirty="0">
+              <a:rPr sz="1000" b="0" i="0" dirty="0">
                 <a:solidFill>
                   <a:srgbClr val="2D3748"/>
                 </a:solidFill>
@@ -3820,7 +3923,7 @@
               <a:t>•  </a:t>
             </a:r>
             <a:r>
-              <a:rPr sz="950" b="0" i="0" dirty="0" err="1">
+              <a:rPr sz="1000" b="0" i="0" dirty="0" err="1">
                 <a:solidFill>
                   <a:srgbClr val="2D3748"/>
                 </a:solidFill>
@@ -3829,7 +3932,7 @@
               <a:t>Orientada</a:t>
             </a:r>
             <a:r>
-              <a:rPr sz="950" b="0" i="0" dirty="0">
+              <a:rPr sz="1000" b="0" i="0" dirty="0">
                 <a:solidFill>
                   <a:srgbClr val="2D3748"/>
                 </a:solidFill>
@@ -3838,7 +3941,7 @@
               <a:t> a </a:t>
             </a:r>
             <a:r>
-              <a:rPr sz="950" b="0" i="0" dirty="0" err="1">
+              <a:rPr sz="1000" b="0" i="0" dirty="0" err="1">
                 <a:solidFill>
                   <a:srgbClr val="2D3748"/>
                 </a:solidFill>
@@ -3847,7 +3950,7 @@
               <a:t>entidad</a:t>
             </a:r>
             <a:r>
-              <a:rPr sz="950" b="0" i="0" dirty="0">
+              <a:rPr sz="1000" b="0" i="0" dirty="0">
                 <a:solidFill>
                   <a:srgbClr val="2D3748"/>
                 </a:solidFill>
@@ -3856,7 +3959,7 @@
               <a:t> de </a:t>
             </a:r>
             <a:r>
-              <a:rPr sz="950" b="0" i="0" dirty="0" err="1">
+              <a:rPr sz="1000" b="0" i="0" dirty="0" err="1">
                 <a:solidFill>
                   <a:srgbClr val="2D3748"/>
                 </a:solidFill>
@@ -3864,7 +3967,7 @@
               </a:rPr>
               <a:t>negocio</a:t>
             </a:r>
-            <a:endParaRPr sz="950" b="0" i="0" dirty="0">
+            <a:endParaRPr sz="1000" b="0" i="0" dirty="0">
               <a:solidFill>
                 <a:srgbClr val="2D3748"/>
               </a:solidFill>
@@ -3878,7 +3981,7 @@
               </a:spcAft>
             </a:pPr>
             <a:r>
-              <a:rPr sz="950" b="0" i="0" dirty="0">
+              <a:rPr sz="1000" b="0" i="0" dirty="0">
                 <a:solidFill>
                   <a:srgbClr val="2D3748"/>
                 </a:solidFill>
@@ -3887,7 +3990,7 @@
               <a:t>•  </a:t>
             </a:r>
             <a:r>
-              <a:rPr sz="950" b="0" i="0" dirty="0" err="1">
+              <a:rPr sz="1000" b="0" i="0" dirty="0" err="1">
                 <a:solidFill>
                   <a:srgbClr val="2D3748"/>
                 </a:solidFill>
@@ -3896,7 +3999,7 @@
               <a:t>Proveedor</a:t>
             </a:r>
             <a:r>
-              <a:rPr sz="950" b="0" i="0" dirty="0">
+              <a:rPr sz="1000" b="0" i="0" dirty="0">
                 <a:solidFill>
                   <a:srgbClr val="2D3748"/>
                 </a:solidFill>
@@ -3905,7 +4008,7 @@
               <a:t> de </a:t>
             </a:r>
             <a:r>
-              <a:rPr sz="950" b="0" i="0" dirty="0" err="1">
+              <a:rPr sz="1000" b="0" i="0" dirty="0" err="1">
                 <a:solidFill>
                   <a:srgbClr val="2D3748"/>
                 </a:solidFill>
@@ -3914,7 +4017,7 @@
               <a:t>identidad</a:t>
             </a:r>
             <a:r>
-              <a:rPr sz="950" b="0" i="0" dirty="0">
+              <a:rPr sz="1000" b="0" i="0" dirty="0">
                 <a:solidFill>
                   <a:srgbClr val="2D3748"/>
                 </a:solidFill>
@@ -3930,7 +4033,7 @@
               </a:spcAft>
             </a:pPr>
             <a:r>
-              <a:rPr sz="950" b="0" i="0" dirty="0">
+              <a:rPr sz="1000" b="0" i="0" dirty="0">
                 <a:solidFill>
                   <a:srgbClr val="2D3748"/>
                 </a:solidFill>
@@ -3939,16 +4042,25 @@
               <a:t>•  .NET Core — Framework .NET </a:t>
             </a:r>
             <a:r>
-              <a:rPr lang="es-ES" sz="950" b="0" i="0" dirty="0">
-                <a:solidFill>
-                  <a:srgbClr val="2D3748"/>
-                </a:solidFill>
-                <a:latin typeface="Calibri"/>
-              </a:rPr>
-              <a:t>8 o superior</a:t>
-            </a:r>
-            <a:r>
-              <a:rPr sz="950" b="0" i="0" dirty="0">
+              <a:rPr lang="es-ES" sz="1000" dirty="0">
+                <a:solidFill>
+                  <a:srgbClr val="2D3748"/>
+                </a:solidFill>
+                <a:latin typeface="Calibri"/>
+              </a:rPr>
+              <a:t>10</a:t>
+            </a:r>
+            <a:r>
+              <a:rPr lang="es-ES" sz="1000" b="0" i="0" dirty="0">
+                <a:solidFill>
+                  <a:srgbClr val="2D3748"/>
+                </a:solidFill>
+                <a:latin typeface="Calibri"/>
+              </a:rPr>
+              <a:t> o superior</a:t>
+            </a:r>
+            <a:r>
+              <a:rPr sz="1000" b="0" i="0" dirty="0">
                 <a:solidFill>
                   <a:srgbClr val="2D3748"/>
                 </a:solidFill>
@@ -4101,7 +4213,7 @@
         <p:spPr>
           <a:xfrm>
             <a:off x="521207" y="2788920"/>
-            <a:ext cx="4946903" cy="512064"/>
+            <a:ext cx="4946903" cy="534505"/>
           </a:xfrm>
           <a:prstGeom prst="rect">
             <a:avLst/>
@@ -4120,13 +4232,67 @@
               </a:spcAft>
             </a:pPr>
             <a:r>
-              <a:rPr sz="950" b="0" i="0">
-                <a:solidFill>
-                  <a:srgbClr val="2D3748"/>
-                </a:solidFill>
-                <a:latin typeface="Calibri"/>
-              </a:rPr>
-              <a:t>•  Versionamiento de API (indicar la versión) — V1</a:t>
+              <a:rPr sz="950" b="0" i="0" dirty="0">
+                <a:solidFill>
+                  <a:srgbClr val="2D3748"/>
+                </a:solidFill>
+                <a:latin typeface="Calibri"/>
+              </a:rPr>
+              <a:t>•  </a:t>
+            </a:r>
+            <a:r>
+              <a:rPr sz="950" b="0" i="0" dirty="0" err="1">
+                <a:solidFill>
+                  <a:srgbClr val="2D3748"/>
+                </a:solidFill>
+                <a:latin typeface="Calibri"/>
+              </a:rPr>
+              <a:t>Versionamiento</a:t>
+            </a:r>
+            <a:r>
+              <a:rPr sz="950" b="0" i="0" dirty="0">
+                <a:solidFill>
+                  <a:srgbClr val="2D3748"/>
+                </a:solidFill>
+                <a:latin typeface="Calibri"/>
+              </a:rPr>
+              <a:t> de API (</a:t>
+            </a:r>
+            <a:r>
+              <a:rPr sz="950" b="0" i="0" dirty="0" err="1">
+                <a:solidFill>
+                  <a:srgbClr val="2D3748"/>
+                </a:solidFill>
+                <a:latin typeface="Calibri"/>
+              </a:rPr>
+              <a:t>indicar</a:t>
+            </a:r>
+            <a:r>
+              <a:rPr sz="950" b="0" i="0" dirty="0">
+                <a:solidFill>
+                  <a:srgbClr val="2D3748"/>
+                </a:solidFill>
+                <a:latin typeface="Calibri"/>
+              </a:rPr>
+              <a:t> la </a:t>
+            </a:r>
+            <a:r>
+              <a:rPr sz="950" b="0" i="0" dirty="0" err="1">
+                <a:solidFill>
+                  <a:srgbClr val="2D3748"/>
+                </a:solidFill>
+                <a:latin typeface="Calibri"/>
+              </a:rPr>
+              <a:t>versión</a:t>
+            </a:r>
+            <a:r>
+              <a:rPr sz="950" b="0" i="0" dirty="0">
+                <a:solidFill>
+                  <a:srgbClr val="2D3748"/>
+                </a:solidFill>
+                <a:latin typeface="Calibri"/>
+              </a:rPr>
+              <a:t>) — V1</a:t>
             </a:r>
           </a:p>
           <a:p>
@@ -4136,13 +4302,67 @@
               </a:spcAft>
             </a:pPr>
             <a:r>
-              <a:rPr sz="950" b="0" i="0">
-                <a:solidFill>
-                  <a:srgbClr val="2D3748"/>
-                </a:solidFill>
-                <a:latin typeface="Calibri"/>
-              </a:rPr>
-              <a:t>•  Uso de sustantivos (según entidad) — API/ALUMNOS</a:t>
+              <a:rPr sz="950" b="0" i="0" dirty="0">
+                <a:solidFill>
+                  <a:srgbClr val="2D3748"/>
+                </a:solidFill>
+                <a:latin typeface="Calibri"/>
+              </a:rPr>
+              <a:t>•  Uso de </a:t>
+            </a:r>
+            <a:r>
+              <a:rPr sz="950" b="0" i="0" dirty="0" err="1">
+                <a:solidFill>
+                  <a:srgbClr val="2D3748"/>
+                </a:solidFill>
+                <a:latin typeface="Calibri"/>
+              </a:rPr>
+              <a:t>sustantivos</a:t>
+            </a:r>
+            <a:r>
+              <a:rPr sz="950" b="0" i="0" dirty="0">
+                <a:solidFill>
+                  <a:srgbClr val="2D3748"/>
+                </a:solidFill>
+                <a:latin typeface="Calibri"/>
+              </a:rPr>
+              <a:t> (</a:t>
+            </a:r>
+            <a:r>
+              <a:rPr sz="950" b="0" i="0" dirty="0" err="1">
+                <a:solidFill>
+                  <a:srgbClr val="2D3748"/>
+                </a:solidFill>
+                <a:latin typeface="Calibri"/>
+              </a:rPr>
+              <a:t>según</a:t>
+            </a:r>
+            <a:r>
+              <a:rPr sz="950" b="0" i="0" dirty="0">
+                <a:solidFill>
+                  <a:srgbClr val="2D3748"/>
+                </a:solidFill>
+                <a:latin typeface="Calibri"/>
+              </a:rPr>
+              <a:t> </a:t>
+            </a:r>
+            <a:r>
+              <a:rPr sz="1000" b="0" i="0" dirty="0" err="1">
+                <a:solidFill>
+                  <a:srgbClr val="2D3748"/>
+                </a:solidFill>
+                <a:latin typeface="Calibri"/>
+              </a:rPr>
+              <a:t>entidad</a:t>
+            </a:r>
+            <a:r>
+              <a:rPr sz="950" b="0" i="0" dirty="0">
+                <a:solidFill>
+                  <a:srgbClr val="2D3748"/>
+                </a:solidFill>
+                <a:latin typeface="Calibri"/>
+              </a:rPr>
+              <a:t>) — API/ALUMNOS</a:t>
             </a:r>
           </a:p>
           <a:p>
@@ -4152,13 +4372,49 @@
               </a:spcAft>
             </a:pPr>
             <a:r>
-              <a:rPr sz="950" b="0" i="0">
-                <a:solidFill>
-                  <a:srgbClr val="2D3748"/>
-                </a:solidFill>
-                <a:latin typeface="Calibri"/>
-              </a:rPr>
-              <a:t>•  Sub-recursos para relaciones — API/ALUMNOS/MATRICULADOS</a:t>
+              <a:rPr sz="950" b="0" i="0" dirty="0">
+                <a:solidFill>
+                  <a:srgbClr val="2D3748"/>
+                </a:solidFill>
+                <a:latin typeface="Calibri"/>
+              </a:rPr>
+              <a:t>•  Sub-</a:t>
+            </a:r>
+            <a:r>
+              <a:rPr sz="950" b="0" i="0" dirty="0" err="1">
+                <a:solidFill>
+                  <a:srgbClr val="2D3748"/>
+                </a:solidFill>
+                <a:latin typeface="Calibri"/>
+              </a:rPr>
+              <a:t>recursos</a:t>
+            </a:r>
+            <a:r>
+              <a:rPr sz="950" b="0" i="0" dirty="0">
+                <a:solidFill>
+                  <a:srgbClr val="2D3748"/>
+                </a:solidFill>
+                <a:latin typeface="Calibri"/>
+              </a:rPr>
+              <a:t> para </a:t>
+            </a:r>
+            <a:r>
+              <a:rPr sz="950" b="0" i="0" dirty="0" err="1">
+                <a:solidFill>
+                  <a:srgbClr val="2D3748"/>
+                </a:solidFill>
+                <a:latin typeface="Calibri"/>
+              </a:rPr>
+              <a:t>relaciones</a:t>
+            </a:r>
+            <a:r>
+              <a:rPr sz="950" b="0" i="0" dirty="0">
+                <a:solidFill>
+                  <a:srgbClr val="2D3748"/>
+                </a:solidFill>
+                <a:latin typeface="Calibri"/>
+              </a:rPr>
+              <a:t> — API/ALUMNOS/MATRICULADOS</a:t>
             </a:r>
           </a:p>
         </p:txBody>
@@ -4412,7 +4668,7 @@
               </a:spcAft>
             </a:pPr>
             <a:r>
-              <a:rPr sz="980" b="1" i="0">
+              <a:rPr sz="980" b="1" i="0" dirty="0">
                 <a:solidFill>
                   <a:srgbClr val="C00000"/>
                 </a:solidFill>
@@ -4421,13 +4677,31 @@
               <a:t>C</a:t>
             </a:r>
             <a:r>
-              <a:rPr sz="950" b="0" i="0">
-                <a:solidFill>
-                  <a:srgbClr val="2D3748"/>
-                </a:solidFill>
-                <a:latin typeface="Calibri"/>
-              </a:rPr>
-              <a:t>reate   →   Método POST</a:t>
+              <a:rPr sz="950" b="0" i="0" dirty="0">
+                <a:solidFill>
+                  <a:srgbClr val="2D3748"/>
+                </a:solidFill>
+                <a:latin typeface="Calibri"/>
+              </a:rPr>
+              <a:t>reate   →   </a:t>
+            </a:r>
+            <a:r>
+              <a:rPr sz="950" b="0" i="0" dirty="0" err="1">
+                <a:solidFill>
+                  <a:srgbClr val="2D3748"/>
+                </a:solidFill>
+                <a:latin typeface="Calibri"/>
+              </a:rPr>
+              <a:t>Método</a:t>
+            </a:r>
+            <a:r>
+              <a:rPr sz="950" b="0" i="0" dirty="0">
+                <a:solidFill>
+                  <a:srgbClr val="2D3748"/>
+                </a:solidFill>
+                <a:latin typeface="Calibri"/>
+              </a:rPr>
+              <a:t> POST</a:t>
             </a:r>
           </a:p>
           <a:p>
@@ -4437,7 +4711,7 @@
               </a:spcAft>
             </a:pPr>
             <a:r>
-              <a:rPr sz="980" b="1" i="0">
+              <a:rPr sz="980" b="1" i="0" dirty="0">
                 <a:solidFill>
                   <a:srgbClr val="C00000"/>
                 </a:solidFill>
@@ -4446,13 +4720,49 @@
               <a:t>R</a:t>
             </a:r>
             <a:r>
-              <a:rPr sz="950" b="0" i="0">
-                <a:solidFill>
-                  <a:srgbClr val="2D3748"/>
-                </a:solidFill>
-                <a:latin typeface="Calibri"/>
-              </a:rPr>
-              <a:t>ead   →   Método de lectura GET</a:t>
+              <a:rPr sz="950" b="0" i="0" dirty="0">
+                <a:solidFill>
+                  <a:srgbClr val="2D3748"/>
+                </a:solidFill>
+                <a:latin typeface="Calibri"/>
+              </a:rPr>
+              <a:t>ead   →   </a:t>
+            </a:r>
+            <a:r>
+              <a:rPr sz="950" b="0" i="0" dirty="0" err="1">
+                <a:solidFill>
+                  <a:srgbClr val="2D3748"/>
+                </a:solidFill>
+                <a:latin typeface="Calibri"/>
+              </a:rPr>
+              <a:t>Método</a:t>
+            </a:r>
+            <a:r>
+              <a:rPr sz="950" b="0" i="0" dirty="0">
+                <a:solidFill>
+                  <a:srgbClr val="2D3748"/>
+                </a:solidFill>
+                <a:latin typeface="Calibri"/>
+              </a:rPr>
+              <a:t> de </a:t>
+            </a:r>
+            <a:r>
+              <a:rPr sz="950" b="0" i="0" dirty="0" err="1">
+                <a:solidFill>
+                  <a:srgbClr val="2D3748"/>
+                </a:solidFill>
+                <a:latin typeface="Calibri"/>
+              </a:rPr>
+              <a:t>lectura</a:t>
+            </a:r>
+            <a:r>
+              <a:rPr sz="950" b="0" i="0" dirty="0">
+                <a:solidFill>
+                  <a:srgbClr val="2D3748"/>
+                </a:solidFill>
+                <a:latin typeface="Calibri"/>
+              </a:rPr>
+              <a:t> GET</a:t>
             </a:r>
           </a:p>
           <a:p>
@@ -4462,7 +4772,7 @@
               </a:spcAft>
             </a:pPr>
             <a:r>
-              <a:rPr sz="980" b="1" i="0">
+              <a:rPr sz="980" b="1" i="0" dirty="0">
                 <a:solidFill>
                   <a:srgbClr val="C00000"/>
                 </a:solidFill>
@@ -4471,13 +4781,49 @@
               <a:t>U</a:t>
             </a:r>
             <a:r>
-              <a:rPr sz="950" b="0" i="0">
-                <a:solidFill>
-                  <a:srgbClr val="2D3748"/>
-                </a:solidFill>
-                <a:latin typeface="Calibri"/>
-              </a:rPr>
-              <a:t>pdate   →   Método de actualización PUT</a:t>
+              <a:rPr sz="950" b="0" i="0" dirty="0">
+                <a:solidFill>
+                  <a:srgbClr val="2D3748"/>
+                </a:solidFill>
+                <a:latin typeface="Calibri"/>
+              </a:rPr>
+              <a:t>pdate   →   </a:t>
+            </a:r>
+            <a:r>
+              <a:rPr sz="950" b="0" i="0" dirty="0" err="1">
+                <a:solidFill>
+                  <a:srgbClr val="2D3748"/>
+                </a:solidFill>
+                <a:latin typeface="Calibri"/>
+              </a:rPr>
+              <a:t>Método</a:t>
+            </a:r>
+            <a:r>
+              <a:rPr sz="950" b="0" i="0" dirty="0">
+                <a:solidFill>
+                  <a:srgbClr val="2D3748"/>
+                </a:solidFill>
+                <a:latin typeface="Calibri"/>
+              </a:rPr>
+              <a:t> de </a:t>
+            </a:r>
+            <a:r>
+              <a:rPr sz="950" b="0" i="0" dirty="0" err="1">
+                <a:solidFill>
+                  <a:srgbClr val="2D3748"/>
+                </a:solidFill>
+                <a:latin typeface="Calibri"/>
+              </a:rPr>
+              <a:t>actualización</a:t>
+            </a:r>
+            <a:r>
+              <a:rPr sz="950" b="0" i="0" dirty="0">
+                <a:solidFill>
+                  <a:srgbClr val="2D3748"/>
+                </a:solidFill>
+                <a:latin typeface="Calibri"/>
+              </a:rPr>
+              <a:t> PUT</a:t>
             </a:r>
           </a:p>
           <a:p>
@@ -4487,7 +4833,7 @@
               </a:spcAft>
             </a:pPr>
             <a:r>
-              <a:rPr sz="980" b="1" i="0">
+              <a:rPr sz="980" b="1" i="0" dirty="0">
                 <a:solidFill>
                   <a:srgbClr val="C00000"/>
                 </a:solidFill>
@@ -4496,13 +4842,49 @@
               <a:t>D</a:t>
             </a:r>
             <a:r>
-              <a:rPr sz="950" b="0" i="0">
-                <a:solidFill>
-                  <a:srgbClr val="2D3748"/>
-                </a:solidFill>
-                <a:latin typeface="Calibri"/>
-              </a:rPr>
-              <a:t>elete   →   Método de eliminación DELETE</a:t>
+              <a:rPr sz="950" b="0" i="0" dirty="0">
+                <a:solidFill>
+                  <a:srgbClr val="2D3748"/>
+                </a:solidFill>
+                <a:latin typeface="Calibri"/>
+              </a:rPr>
+              <a:t>elete   →   </a:t>
+            </a:r>
+            <a:r>
+              <a:rPr sz="950" b="0" i="0" dirty="0" err="1">
+                <a:solidFill>
+                  <a:srgbClr val="2D3748"/>
+                </a:solidFill>
+                <a:latin typeface="Calibri"/>
+              </a:rPr>
+              <a:t>Método</a:t>
+            </a:r>
+            <a:r>
+              <a:rPr sz="950" b="0" i="0" dirty="0">
+                <a:solidFill>
+                  <a:srgbClr val="2D3748"/>
+                </a:solidFill>
+                <a:latin typeface="Calibri"/>
+              </a:rPr>
+              <a:t> de </a:t>
+            </a:r>
+            <a:r>
+              <a:rPr sz="950" b="0" i="0" dirty="0" err="1">
+                <a:solidFill>
+                  <a:srgbClr val="2D3748"/>
+                </a:solidFill>
+                <a:latin typeface="Calibri"/>
+              </a:rPr>
+              <a:t>eliminación</a:t>
+            </a:r>
+            <a:r>
+              <a:rPr sz="950" b="0" i="0" dirty="0">
+                <a:solidFill>
+                  <a:srgbClr val="2D3748"/>
+                </a:solidFill>
+                <a:latin typeface="Calibri"/>
+              </a:rPr>
+              <a:t> DELETE</a:t>
             </a:r>
           </a:p>
         </p:txBody>
@@ -4668,13 +5050,49 @@
               </a:spcAft>
             </a:pPr>
             <a:r>
-              <a:rPr sz="930" b="0" i="0">
-                <a:solidFill>
-                  <a:srgbClr val="2D3748"/>
-                </a:solidFill>
-                <a:latin typeface="Calibri"/>
-              </a:rPr>
-              <a:t>•  Json Web Token   →   Proveedor de identidad Azure AD</a:t>
+              <a:rPr sz="930" b="0" i="0" dirty="0">
+                <a:solidFill>
+                  <a:srgbClr val="2D3748"/>
+                </a:solidFill>
+                <a:latin typeface="Calibri"/>
+              </a:rPr>
+              <a:t>•  Json Web Token   →   </a:t>
+            </a:r>
+            <a:r>
+              <a:rPr sz="930" b="0" i="0" dirty="0" err="1">
+                <a:solidFill>
+                  <a:srgbClr val="2D3748"/>
+                </a:solidFill>
+                <a:latin typeface="Calibri"/>
+              </a:rPr>
+              <a:t>Proveedor</a:t>
+            </a:r>
+            <a:r>
+              <a:rPr sz="930" b="0" i="0" dirty="0">
+                <a:solidFill>
+                  <a:srgbClr val="2D3748"/>
+                </a:solidFill>
+                <a:latin typeface="Calibri"/>
+              </a:rPr>
+              <a:t> de </a:t>
+            </a:r>
+            <a:r>
+              <a:rPr sz="930" b="0" i="0" dirty="0" err="1">
+                <a:solidFill>
+                  <a:srgbClr val="2D3748"/>
+                </a:solidFill>
+                <a:latin typeface="Calibri"/>
+              </a:rPr>
+              <a:t>identidad</a:t>
+            </a:r>
+            <a:r>
+              <a:rPr sz="930" b="0" i="0" dirty="0">
+                <a:solidFill>
+                  <a:srgbClr val="2D3748"/>
+                </a:solidFill>
+                <a:latin typeface="Calibri"/>
+              </a:rPr>
+              <a:t> Azure AD</a:t>
             </a:r>
           </a:p>
           <a:p>
@@ -4684,13 +5102,49 @@
               </a:spcAft>
             </a:pPr>
             <a:r>
-              <a:rPr sz="930" b="0" i="0">
-                <a:solidFill>
-                  <a:srgbClr val="2D3748"/>
-                </a:solidFill>
-                <a:latin typeface="Calibri"/>
-              </a:rPr>
-              <a:t>•  Clave de API (x-xmsbs-apikey)   →   Azure Key Vault</a:t>
+              <a:rPr sz="930" b="0" i="0" dirty="0">
+                <a:solidFill>
+                  <a:srgbClr val="2D3748"/>
+                </a:solidFill>
+                <a:latin typeface="Calibri"/>
+              </a:rPr>
+              <a:t>•  Clave de API (x-</a:t>
+            </a:r>
+            <a:r>
+              <a:rPr sz="930" b="0" i="0" dirty="0" err="1">
+                <a:solidFill>
+                  <a:srgbClr val="2D3748"/>
+                </a:solidFill>
+                <a:latin typeface="Calibri"/>
+              </a:rPr>
+              <a:t>xmsbs</a:t>
+            </a:r>
+            <a:r>
+              <a:rPr sz="930" b="0" i="0" dirty="0">
+                <a:solidFill>
+                  <a:srgbClr val="2D3748"/>
+                </a:solidFill>
+                <a:latin typeface="Calibri"/>
+              </a:rPr>
+              <a:t>-</a:t>
+            </a:r>
+            <a:r>
+              <a:rPr sz="930" b="0" i="0" dirty="0" err="1">
+                <a:solidFill>
+                  <a:srgbClr val="2D3748"/>
+                </a:solidFill>
+                <a:latin typeface="Calibri"/>
+              </a:rPr>
+              <a:t>apikey</a:t>
+            </a:r>
+            <a:r>
+              <a:rPr sz="930" b="0" i="0" dirty="0">
+                <a:solidFill>
+                  <a:srgbClr val="2D3748"/>
+                </a:solidFill>
+                <a:latin typeface="Calibri"/>
+              </a:rPr>
+              <a:t>)   →   Azure Key Vault</a:t>
             </a:r>
           </a:p>
         </p:txBody>
@@ -5268,7 +5722,7 @@
         <p:spPr>
           <a:xfrm>
             <a:off x="6099048" y="1298448"/>
-            <a:ext cx="3246120" cy="1051560"/>
+            <a:ext cx="3319272" cy="908967"/>
           </a:xfrm>
           <a:prstGeom prst="rect">
             <a:avLst/>
@@ -5287,13 +5741,49 @@
               </a:spcAft>
             </a:pPr>
             <a:r>
-              <a:rPr sz="1000" b="0" i="0">
-                <a:solidFill>
-                  <a:srgbClr val="2D3748"/>
-                </a:solidFill>
-                <a:latin typeface="Calibri"/>
-              </a:rPr>
-              <a:t>•  Documentación con Swagger (OpenAPI)</a:t>
+              <a:rPr sz="1000" b="0" i="0" dirty="0">
+                <a:solidFill>
+                  <a:srgbClr val="2D3748"/>
+                </a:solidFill>
+                <a:latin typeface="Calibri"/>
+              </a:rPr>
+              <a:t>•  </a:t>
+            </a:r>
+            <a:r>
+              <a:rPr sz="1000" b="0" i="0" dirty="0" err="1">
+                <a:solidFill>
+                  <a:srgbClr val="2D3748"/>
+                </a:solidFill>
+                <a:latin typeface="Calibri"/>
+              </a:rPr>
+              <a:t>Documentación</a:t>
+            </a:r>
+            <a:r>
+              <a:rPr sz="1000" b="0" i="0" dirty="0">
+                <a:solidFill>
+                  <a:srgbClr val="2D3748"/>
+                </a:solidFill>
+                <a:latin typeface="Calibri"/>
+              </a:rPr>
+              <a:t> con Swagger (</a:t>
+            </a:r>
+            <a:r>
+              <a:rPr sz="1000" b="0" i="0" dirty="0" err="1">
+                <a:solidFill>
+                  <a:srgbClr val="2D3748"/>
+                </a:solidFill>
+                <a:latin typeface="Calibri"/>
+              </a:rPr>
+              <a:t>OpenAPI</a:t>
+            </a:r>
+            <a:r>
+              <a:rPr sz="1000" b="0" i="0" dirty="0">
+                <a:solidFill>
+                  <a:srgbClr val="2D3748"/>
+                </a:solidFill>
+                <a:latin typeface="Calibri"/>
+              </a:rPr>
+              <a:t>)</a:t>
             </a:r>
           </a:p>
           <a:p>
@@ -5303,13 +5793,31 @@
               </a:spcAft>
             </a:pPr>
             <a:r>
-              <a:rPr sz="930" b="0" i="0">
-                <a:solidFill>
-                  <a:srgbClr val="2D3748"/>
-                </a:solidFill>
-                <a:latin typeface="Calibri"/>
-              </a:rPr>
-              <a:t>     ▸ Información general de la API</a:t>
+              <a:rPr sz="1000" b="0" i="0" dirty="0">
+                <a:solidFill>
+                  <a:srgbClr val="2D3748"/>
+                </a:solidFill>
+                <a:latin typeface="Calibri"/>
+              </a:rPr>
+              <a:t>     ▸ </a:t>
+            </a:r>
+            <a:r>
+              <a:rPr sz="1000" b="0" i="0" dirty="0" err="1">
+                <a:solidFill>
+                  <a:srgbClr val="2D3748"/>
+                </a:solidFill>
+                <a:latin typeface="Calibri"/>
+              </a:rPr>
+              <a:t>Información</a:t>
+            </a:r>
+            <a:r>
+              <a:rPr sz="1000" b="0" i="0" dirty="0">
+                <a:solidFill>
+                  <a:srgbClr val="2D3748"/>
+                </a:solidFill>
+                <a:latin typeface="Calibri"/>
+              </a:rPr>
+              <a:t> general de la API</a:t>
             </a:r>
           </a:p>
           <a:p>
@@ -5319,13 +5827,31 @@
               </a:spcAft>
             </a:pPr>
             <a:r>
-              <a:rPr sz="930" b="0" i="0">
-                <a:solidFill>
-                  <a:srgbClr val="2D3748"/>
-                </a:solidFill>
-                <a:latin typeface="Calibri"/>
-              </a:rPr>
-              <a:t>     ▸ Rutas disponibles (endpoints)</a:t>
+              <a:rPr sz="1000" b="0" i="0" dirty="0">
+                <a:solidFill>
+                  <a:srgbClr val="2D3748"/>
+                </a:solidFill>
+                <a:latin typeface="Calibri"/>
+              </a:rPr>
+              <a:t>     ▸ Rutas </a:t>
+            </a:r>
+            <a:r>
+              <a:rPr sz="1000" b="0" i="0" dirty="0" err="1">
+                <a:solidFill>
+                  <a:srgbClr val="2D3748"/>
+                </a:solidFill>
+                <a:latin typeface="Calibri"/>
+              </a:rPr>
+              <a:t>disponibles</a:t>
+            </a:r>
+            <a:r>
+              <a:rPr sz="1000" b="0" i="0" dirty="0">
+                <a:solidFill>
+                  <a:srgbClr val="2D3748"/>
+                </a:solidFill>
+                <a:latin typeface="Calibri"/>
+              </a:rPr>
+              <a:t> (endpoints)</a:t>
             </a:r>
           </a:p>
           <a:p>
@@ -5335,13 +5861,49 @@
               </a:spcAft>
             </a:pPr>
             <a:r>
-              <a:rPr sz="930" b="0" i="0">
-                <a:solidFill>
-                  <a:srgbClr val="2D3748"/>
-                </a:solidFill>
-                <a:latin typeface="Calibri"/>
-              </a:rPr>
-              <a:t>     ▸ Operaciones disponibles (PUT, GET…)</a:t>
+              <a:rPr sz="1000" b="0" i="0" dirty="0">
+                <a:solidFill>
+                  <a:srgbClr val="2D3748"/>
+                </a:solidFill>
+                <a:latin typeface="Calibri"/>
+              </a:rPr>
+              <a:t>     ▸ </a:t>
+            </a:r>
+            <a:r>
+              <a:rPr sz="1000" b="0" i="0" dirty="0" err="1">
+                <a:solidFill>
+                  <a:srgbClr val="2D3748"/>
+                </a:solidFill>
+                <a:latin typeface="Calibri"/>
+              </a:rPr>
+              <a:t>Operaciones</a:t>
+            </a:r>
+            <a:r>
+              <a:rPr sz="1000" b="0" i="0" dirty="0">
+                <a:solidFill>
+                  <a:srgbClr val="2D3748"/>
+                </a:solidFill>
+                <a:latin typeface="Calibri"/>
+              </a:rPr>
+              <a:t> </a:t>
+            </a:r>
+            <a:r>
+              <a:rPr sz="1000" b="0" i="0" dirty="0" err="1">
+                <a:solidFill>
+                  <a:srgbClr val="2D3748"/>
+                </a:solidFill>
+                <a:latin typeface="Calibri"/>
+              </a:rPr>
+              <a:t>disponibles</a:t>
+            </a:r>
+            <a:r>
+              <a:rPr sz="1000" b="0" i="0" dirty="0">
+                <a:solidFill>
+                  <a:srgbClr val="2D3748"/>
+                </a:solidFill>
+                <a:latin typeface="Calibri"/>
+              </a:rPr>
+              <a:t> (PUT, GET…)</a:t>
             </a:r>
           </a:p>
           <a:p>
@@ -5351,14 +5913,47 @@
               </a:spcAft>
             </a:pPr>
             <a:r>
-              <a:rPr sz="930" b="0" i="0">
-                <a:solidFill>
-                  <a:srgbClr val="2D3748"/>
-                </a:solidFill>
-                <a:latin typeface="Calibri"/>
-              </a:rPr>
-              <a:t>     ▸ Request y response de cada operación</a:t>
-            </a:r>
+              <a:rPr sz="1000" b="0" i="0" dirty="0">
+                <a:solidFill>
+                  <a:srgbClr val="2D3748"/>
+                </a:solidFill>
+                <a:latin typeface="Calibri"/>
+              </a:rPr>
+              <a:t>     ▸ Request y response de </a:t>
+            </a:r>
+            <a:r>
+              <a:rPr sz="1000" b="0" i="0" dirty="0" err="1">
+                <a:solidFill>
+                  <a:srgbClr val="2D3748"/>
+                </a:solidFill>
+                <a:latin typeface="Calibri"/>
+              </a:rPr>
+              <a:t>cada</a:t>
+            </a:r>
+            <a:r>
+              <a:rPr sz="1000" b="0" i="0" dirty="0">
+                <a:solidFill>
+                  <a:srgbClr val="2D3748"/>
+                </a:solidFill>
+                <a:latin typeface="Calibri"/>
+              </a:rPr>
+              <a:t> </a:t>
+            </a:r>
+            <a:r>
+              <a:rPr sz="1000" b="0" i="0" dirty="0" err="1">
+                <a:solidFill>
+                  <a:srgbClr val="2D3748"/>
+                </a:solidFill>
+                <a:latin typeface="Calibri"/>
+              </a:rPr>
+              <a:t>operación</a:t>
+            </a:r>
+            <a:endParaRPr sz="1000" b="0" i="0" dirty="0">
+              <a:solidFill>
+                <a:srgbClr val="2D3748"/>
+              </a:solidFill>
+              <a:latin typeface="Calibri"/>
+            </a:endParaRPr>
           </a:p>
         </p:txBody>
       </p:sp>
@@ -5964,8 +6559,8 @@
         </p:nvSpPr>
         <p:spPr>
           <a:xfrm>
-            <a:off x="7955279" y="2944368"/>
-            <a:ext cx="3703320" cy="342900"/>
+            <a:off x="7955279" y="3020407"/>
+            <a:ext cx="3703320" cy="190821"/>
           </a:xfrm>
           <a:prstGeom prst="rect">
             <a:avLst/>
@@ -5984,13 +6579,22 @@
               </a:spcAft>
             </a:pPr>
             <a:r>
-              <a:rPr sz="900" b="0" i="0">
-                <a:solidFill>
-                  <a:srgbClr val="2D3748"/>
-                </a:solidFill>
-                <a:latin typeface="Calibri"/>
-              </a:rPr>
-              <a:t>Controlador de API (endpoint)</a:t>
+              <a:rPr sz="1000" b="0" i="0" dirty="0" err="1">
+                <a:solidFill>
+                  <a:srgbClr val="2D3748"/>
+                </a:solidFill>
+                <a:latin typeface="Calibri"/>
+              </a:rPr>
+              <a:t>Controlador</a:t>
+            </a:r>
+            <a:r>
+              <a:rPr sz="1000" b="0" i="0" dirty="0">
+                <a:solidFill>
+                  <a:srgbClr val="2D3748"/>
+                </a:solidFill>
+                <a:latin typeface="Calibri"/>
+              </a:rPr>
+              <a:t> de API (endpoint)</a:t>
             </a:r>
           </a:p>
         </p:txBody>
@@ -6089,8 +6693,8 @@
         </p:nvSpPr>
         <p:spPr>
           <a:xfrm>
-            <a:off x="7955279" y="3360420"/>
-            <a:ext cx="3703320" cy="342900"/>
+            <a:off x="7955279" y="3436459"/>
+            <a:ext cx="3703320" cy="190821"/>
           </a:xfrm>
           <a:prstGeom prst="rect">
             <a:avLst/>
@@ -6109,13 +6713,76 @@
               </a:spcAft>
             </a:pPr>
             <a:r>
-              <a:rPr sz="900" b="0" i="0">
-                <a:solidFill>
-                  <a:srgbClr val="2D3748"/>
-                </a:solidFill>
-                <a:latin typeface="Calibri"/>
-              </a:rPr>
-              <a:t>Gestión de respuesta (recibe la solicitud HTTP)</a:t>
+              <a:rPr sz="1000" b="0" i="0" dirty="0" err="1">
+                <a:solidFill>
+                  <a:srgbClr val="2D3748"/>
+                </a:solidFill>
+                <a:latin typeface="Calibri"/>
+              </a:rPr>
+              <a:t>Gestión</a:t>
+            </a:r>
+            <a:r>
+              <a:rPr sz="1000" b="0" i="0" dirty="0">
+                <a:solidFill>
+                  <a:srgbClr val="2D3748"/>
+                </a:solidFill>
+                <a:latin typeface="Calibri"/>
+              </a:rPr>
+              <a:t> de </a:t>
+            </a:r>
+            <a:r>
+              <a:rPr sz="1000" b="0" i="0" dirty="0" err="1">
+                <a:solidFill>
+                  <a:srgbClr val="2D3748"/>
+                </a:solidFill>
+                <a:latin typeface="Calibri"/>
+              </a:rPr>
+              <a:t>respuesta</a:t>
+            </a:r>
+            <a:r>
+              <a:rPr sz="1000" b="0" i="0" dirty="0">
+                <a:solidFill>
+                  <a:srgbClr val="2D3748"/>
+                </a:solidFill>
+                <a:latin typeface="Calibri"/>
+              </a:rPr>
+              <a:t> (</a:t>
+            </a:r>
+            <a:r>
+              <a:rPr sz="1000" b="0" i="0" dirty="0" err="1">
+                <a:solidFill>
+                  <a:srgbClr val="2D3748"/>
+                </a:solidFill>
+                <a:latin typeface="Calibri"/>
+              </a:rPr>
+              <a:t>recibe</a:t>
+            </a:r>
+            <a:r>
+              <a:rPr sz="1000" b="0" i="0" dirty="0">
+                <a:solidFill>
+                  <a:srgbClr val="2D3748"/>
+                </a:solidFill>
+                <a:latin typeface="Calibri"/>
+              </a:rPr>
+              <a:t> la </a:t>
+            </a:r>
+            <a:r>
+              <a:rPr sz="1000" b="0" i="0" dirty="0" err="1">
+                <a:solidFill>
+                  <a:srgbClr val="2D3748"/>
+                </a:solidFill>
+                <a:latin typeface="Calibri"/>
+              </a:rPr>
+              <a:t>solicitud</a:t>
+            </a:r>
+            <a:r>
+              <a:rPr sz="1000" b="0" i="0" dirty="0">
+                <a:solidFill>
+                  <a:srgbClr val="2D3748"/>
+                </a:solidFill>
+                <a:latin typeface="Calibri"/>
+              </a:rPr>
+              <a:t> HTTP)</a:t>
             </a:r>
           </a:p>
         </p:txBody>
@@ -6214,8 +6881,8 @@
         </p:nvSpPr>
         <p:spPr>
           <a:xfrm>
-            <a:off x="7955279" y="3776472"/>
-            <a:ext cx="3703320" cy="342900"/>
+            <a:off x="7955279" y="3852511"/>
+            <a:ext cx="3703320" cy="190821"/>
           </a:xfrm>
           <a:prstGeom prst="rect">
             <a:avLst/>
@@ -6234,7 +6901,7 @@
               </a:spcAft>
             </a:pPr>
             <a:r>
-              <a:rPr sz="900" b="1" i="0">
+              <a:rPr sz="1000" b="1" i="0">
                 <a:solidFill>
                   <a:srgbClr val="1E7D32"/>
                 </a:solidFill>
@@ -6339,8 +7006,8 @@
         </p:nvSpPr>
         <p:spPr>
           <a:xfrm>
-            <a:off x="7955279" y="4192524"/>
-            <a:ext cx="3703320" cy="342900"/>
+            <a:off x="7955279" y="4268563"/>
+            <a:ext cx="3703320" cy="190821"/>
           </a:xfrm>
           <a:prstGeom prst="rect">
             <a:avLst/>
@@ -6359,7 +7026,7 @@
               </a:spcAft>
             </a:pPr>
             <a:r>
-              <a:rPr sz="900" b="0" i="0">
+              <a:rPr sz="1000" b="0" i="0">
                 <a:solidFill>
                   <a:srgbClr val="2D3748"/>
                 </a:solidFill>
@@ -6464,8 +7131,8 @@
         </p:nvSpPr>
         <p:spPr>
           <a:xfrm>
-            <a:off x="7955279" y="4608576"/>
-            <a:ext cx="3703320" cy="342900"/>
+            <a:off x="7955279" y="4684615"/>
+            <a:ext cx="3703320" cy="190821"/>
           </a:xfrm>
           <a:prstGeom prst="rect">
             <a:avLst/>
@@ -6484,7 +7151,7 @@
               </a:spcAft>
             </a:pPr>
             <a:r>
-              <a:rPr sz="900" b="0" i="0">
+              <a:rPr sz="1000" b="0" i="0">
                 <a:solidFill>
                   <a:srgbClr val="2D3748"/>
                 </a:solidFill>
@@ -6589,8 +7256,8 @@
         </p:nvSpPr>
         <p:spPr>
           <a:xfrm>
-            <a:off x="7955279" y="5024628"/>
-            <a:ext cx="3703320" cy="342900"/>
+            <a:off x="7955279" y="5100667"/>
+            <a:ext cx="3703320" cy="190821"/>
           </a:xfrm>
           <a:prstGeom prst="rect">
             <a:avLst/>
@@ -6609,7 +7276,7 @@
               </a:spcAft>
             </a:pPr>
             <a:r>
-              <a:rPr sz="900" b="0" i="0">
+              <a:rPr sz="1000" b="0" i="0">
                 <a:solidFill>
                   <a:srgbClr val="2D3748"/>
                 </a:solidFill>
@@ -6714,8 +7381,8 @@
         </p:nvSpPr>
         <p:spPr>
           <a:xfrm>
-            <a:off x="7955279" y="5440680"/>
-            <a:ext cx="3703320" cy="342900"/>
+            <a:off x="7955279" y="5516719"/>
+            <a:ext cx="3703320" cy="190821"/>
           </a:xfrm>
           <a:prstGeom prst="rect">
             <a:avLst/>
@@ -6734,7 +7401,7 @@
               </a:spcAft>
             </a:pPr>
             <a:r>
-              <a:rPr sz="900" b="0" i="0">
+              <a:rPr sz="1000" b="0" i="0">
                 <a:solidFill>
                   <a:srgbClr val="2D3748"/>
                 </a:solidFill>
@@ -6839,8 +7506,8 @@
         </p:nvSpPr>
         <p:spPr>
           <a:xfrm>
-            <a:off x="7955279" y="5856732"/>
-            <a:ext cx="3703320" cy="342900"/>
+            <a:off x="7955279" y="5932771"/>
+            <a:ext cx="3703320" cy="190821"/>
           </a:xfrm>
           <a:prstGeom prst="rect">
             <a:avLst/>
@@ -6859,7 +7526,7 @@
               </a:spcAft>
             </a:pPr>
             <a:r>
-              <a:rPr sz="900" b="0" i="0">
+              <a:rPr sz="1000" b="0" i="0">
                 <a:solidFill>
                   <a:srgbClr val="2D3748"/>
                 </a:solidFill>
@@ -7416,7 +8083,26 @@
                 <a:effectLst/>
                 <a:latin typeface="Arial" panose="020B0604020202020204" pitchFamily="34" charset="0"/>
               </a:rPr>
-              <a:t>endpoint</a:t>
+              <a:t>End</a:t>
+            </a:r>
+            <a:r>
+              <a:rPr lang="es-CL" sz="1100" b="1" dirty="0" err="1">
+                <a:solidFill>
+                  <a:srgbClr val="333333"/>
+                </a:solidFill>
+                <a:latin typeface="Arial" panose="020B0604020202020204" pitchFamily="34" charset="0"/>
+              </a:rPr>
+              <a:t>P</a:t>
+            </a:r>
+            <a:r>
+              <a:rPr lang="es-CL" sz="1100" b="1" i="0" dirty="0" err="1">
+                <a:solidFill>
+                  <a:srgbClr val="333333"/>
+                </a:solidFill>
+                <a:effectLst/>
+                <a:latin typeface="Arial" panose="020B0604020202020204" pitchFamily="34" charset="0"/>
+              </a:rPr>
+              <a:t>oint</a:t>
             </a:r>
             <a:r>
               <a:rPr lang="es-CL" sz="1100" b="1" i="0" dirty="0">
@@ -7681,25 +8367,7 @@
                 </a:solidFill>
                 <a:latin typeface="Arial" panose="020B0604020202020204" pitchFamily="34" charset="0"/>
               </a:rPr>
-              <a:t>Ejemplo del </a:t>
-            </a:r>
-            <a:r>
-              <a:rPr lang="es-CL" sz="1100" b="1" dirty="0" err="1">
-                <a:solidFill>
-                  <a:srgbClr val="333333"/>
-                </a:solidFill>
-                <a:latin typeface="Arial" panose="020B0604020202020204" pitchFamily="34" charset="0"/>
-              </a:rPr>
-              <a:t>json</a:t>
-            </a:r>
-            <a:r>
-              <a:rPr lang="es-CL" sz="1100" b="1" dirty="0">
-                <a:solidFill>
-                  <a:srgbClr val="333333"/>
-                </a:solidFill>
-                <a:latin typeface="Arial" panose="020B0604020202020204" pitchFamily="34" charset="0"/>
-              </a:rPr>
-              <a:t> de respuesta</a:t>
+              <a:t>Ejemplo del JSON de respuesta</a:t>
             </a:r>
             <a:endParaRPr lang="es-CL" sz="1100" b="1" i="0" dirty="0">
               <a:solidFill>

</xml_diff>